<commit_message>
Configurar usuarios institucionales permanentes para Render y actualizar manuales oficiales
</commit_message>
<xml_diff>
--- a/PRESENTACION_ACADEMIX_FINAL.pptx
+++ b/PRESENTACION_ACADEMIX_FINAL.pptx
@@ -5,18 +5,18 @@
     <p:sldMasterId id="2147483648" r:id="rId1"/>
   </p:sldMasterIdLst>
   <p:sldIdLst>
-    <p:sldId id="256" r:id="rId7"/>
-    <p:sldId id="257" r:id="rId8"/>
-    <p:sldId id="258" r:id="rId9"/>
-    <p:sldId id="259" r:id="rId10"/>
-    <p:sldId id="260" r:id="rId11"/>
-    <p:sldId id="261" r:id="rId12"/>
-    <p:sldId id="262" r:id="rId13"/>
-    <p:sldId id="263" r:id="rId14"/>
-    <p:sldId id="264" r:id="rId15"/>
-    <p:sldId id="265" r:id="rId16"/>
+    <p:sldId id="256" r:id="rId2"/>
+    <p:sldId id="257" r:id="rId3"/>
+    <p:sldId id="258" r:id="rId4"/>
+    <p:sldId id="259" r:id="rId5"/>
+    <p:sldId id="260" r:id="rId6"/>
+    <p:sldId id="261" r:id="rId7"/>
+    <p:sldId id="262" r:id="rId8"/>
+    <p:sldId id="263" r:id="rId9"/>
+    <p:sldId id="264" r:id="rId10"/>
+    <p:sldId id="265" r:id="rId11"/>
   </p:sldIdLst>
-  <p:sldSz cx="12191695" cy="6858000" type="screen4x3"/>
+  <p:sldSz cx="12192000" cy="6858000"/>
   <p:notesSz cx="6858000" cy="9144000"/>
   <p:defaultTextStyle>
     <a:defPPr>
@@ -113,6 +113,22 @@
       </a:defRPr>
     </a:lvl9pPr>
   </p:defaultTextStyle>
+  <p:extLst>
+    <p:ext uri="{EFAFB233-063F-42B5-8137-9DF3F51BA10A}">
+      <p15:sldGuideLst xmlns:p15="http://schemas.microsoft.com/office/powerpoint/2012/main">
+        <p15:guide id="1" orient="horz" pos="2160">
+          <p15:clr>
+            <a:srgbClr val="A4A3A4"/>
+          </p15:clr>
+        </p15:guide>
+        <p15:guide id="2" pos="2880">
+          <p15:clr>
+            <a:srgbClr val="A4A3A4"/>
+          </p15:clr>
+        </p15:guide>
+      </p15:sldGuideLst>
+    </p:ext>
+  </p:extLst>
 </p:presentation>
 </file>
 
@@ -297,7 +313,7 @@
           <a:p>
             <a:fld id="{5BCAD085-E8A6-8845-BD4E-CB4CCA059FC4}" type="datetimeFigureOut">
               <a:rPr lang="en-US" smtClean="0"/>
-              <a:t>1/27/13</a:t>
+              <a:t>10/27/2026</a:t>
             </a:fld>
             <a:endParaRPr lang="en-US"/>
           </a:p>
@@ -339,7 +355,7 @@
           <a:p>
             <a:fld id="{C1FF6DA9-008F-8B48-92A6-B652298478BF}" type="slidenum">
               <a:rPr lang="en-US" smtClean="0"/>
-              <a:t>‹#›</a:t>
+              <a:t>‹Nº›</a:t>
             </a:fld>
             <a:endParaRPr lang="en-US"/>
           </a:p>
@@ -467,7 +483,7 @@
           <a:p>
             <a:fld id="{5BCAD085-E8A6-8845-BD4E-CB4CCA059FC4}" type="datetimeFigureOut">
               <a:rPr lang="en-US" smtClean="0"/>
-              <a:t>1/27/13</a:t>
+              <a:t>10/27/2026</a:t>
             </a:fld>
             <a:endParaRPr lang="en-US"/>
           </a:p>
@@ -509,7 +525,7 @@
           <a:p>
             <a:fld id="{C1FF6DA9-008F-8B48-92A6-B652298478BF}" type="slidenum">
               <a:rPr lang="en-US" smtClean="0"/>
-              <a:t>‹#›</a:t>
+              <a:t>‹Nº›</a:t>
             </a:fld>
             <a:endParaRPr lang="en-US"/>
           </a:p>
@@ -647,7 +663,7 @@
           <a:p>
             <a:fld id="{5BCAD085-E8A6-8845-BD4E-CB4CCA059FC4}" type="datetimeFigureOut">
               <a:rPr lang="en-US" smtClean="0"/>
-              <a:t>1/27/13</a:t>
+              <a:t>10/27/2026</a:t>
             </a:fld>
             <a:endParaRPr lang="en-US"/>
           </a:p>
@@ -689,7 +705,7 @@
           <a:p>
             <a:fld id="{C1FF6DA9-008F-8B48-92A6-B652298478BF}" type="slidenum">
               <a:rPr lang="en-US" smtClean="0"/>
-              <a:t>‹#›</a:t>
+              <a:t>‹Nº›</a:t>
             </a:fld>
             <a:endParaRPr lang="en-US"/>
           </a:p>
@@ -817,7 +833,7 @@
           <a:p>
             <a:fld id="{5BCAD085-E8A6-8845-BD4E-CB4CCA059FC4}" type="datetimeFigureOut">
               <a:rPr lang="en-US" smtClean="0"/>
-              <a:t>1/27/13</a:t>
+              <a:t>10/27/2026</a:t>
             </a:fld>
             <a:endParaRPr lang="en-US"/>
           </a:p>
@@ -859,7 +875,7 @@
           <a:p>
             <a:fld id="{C1FF6DA9-008F-8B48-92A6-B652298478BF}" type="slidenum">
               <a:rPr lang="en-US" smtClean="0"/>
-              <a:t>‹#›</a:t>
+              <a:t>‹Nº›</a:t>
             </a:fld>
             <a:endParaRPr lang="en-US"/>
           </a:p>
@@ -1063,7 +1079,7 @@
           <a:p>
             <a:fld id="{5BCAD085-E8A6-8845-BD4E-CB4CCA059FC4}" type="datetimeFigureOut">
               <a:rPr lang="en-US" smtClean="0"/>
-              <a:t>1/27/13</a:t>
+              <a:t>10/27/2026</a:t>
             </a:fld>
             <a:endParaRPr lang="en-US"/>
           </a:p>
@@ -1105,7 +1121,7 @@
           <a:p>
             <a:fld id="{C1FF6DA9-008F-8B48-92A6-B652298478BF}" type="slidenum">
               <a:rPr lang="en-US" smtClean="0"/>
-              <a:t>‹#›</a:t>
+              <a:t>‹Nº›</a:t>
             </a:fld>
             <a:endParaRPr lang="en-US"/>
           </a:p>
@@ -1351,7 +1367,7 @@
           <a:p>
             <a:fld id="{5BCAD085-E8A6-8845-BD4E-CB4CCA059FC4}" type="datetimeFigureOut">
               <a:rPr lang="en-US" smtClean="0"/>
-              <a:t>1/27/13</a:t>
+              <a:t>10/27/2026</a:t>
             </a:fld>
             <a:endParaRPr lang="en-US"/>
           </a:p>
@@ -1393,7 +1409,7 @@
           <a:p>
             <a:fld id="{C1FF6DA9-008F-8B48-92A6-B652298478BF}" type="slidenum">
               <a:rPr lang="en-US" smtClean="0"/>
-              <a:t>‹#›</a:t>
+              <a:t>‹Nº›</a:t>
             </a:fld>
             <a:endParaRPr lang="en-US"/>
           </a:p>
@@ -1773,7 +1789,7 @@
           <a:p>
             <a:fld id="{5BCAD085-E8A6-8845-BD4E-CB4CCA059FC4}" type="datetimeFigureOut">
               <a:rPr lang="en-US" smtClean="0"/>
-              <a:t>1/27/13</a:t>
+              <a:t>10/27/2026</a:t>
             </a:fld>
             <a:endParaRPr lang="en-US"/>
           </a:p>
@@ -1815,7 +1831,7 @@
           <a:p>
             <a:fld id="{C1FF6DA9-008F-8B48-92A6-B652298478BF}" type="slidenum">
               <a:rPr lang="en-US" smtClean="0"/>
-              <a:t>‹#›</a:t>
+              <a:t>‹Nº›</a:t>
             </a:fld>
             <a:endParaRPr lang="en-US"/>
           </a:p>
@@ -1891,7 +1907,7 @@
           <a:p>
             <a:fld id="{5BCAD085-E8A6-8845-BD4E-CB4CCA059FC4}" type="datetimeFigureOut">
               <a:rPr lang="en-US" smtClean="0"/>
-              <a:t>1/27/13</a:t>
+              <a:t>10/27/2026</a:t>
             </a:fld>
             <a:endParaRPr lang="en-US"/>
           </a:p>
@@ -1933,7 +1949,7 @@
           <a:p>
             <a:fld id="{C1FF6DA9-008F-8B48-92A6-B652298478BF}" type="slidenum">
               <a:rPr lang="en-US" smtClean="0"/>
-              <a:t>‹#›</a:t>
+              <a:t>‹Nº›</a:t>
             </a:fld>
             <a:endParaRPr lang="en-US"/>
           </a:p>
@@ -1986,7 +2002,7 @@
           <a:p>
             <a:fld id="{5BCAD085-E8A6-8845-BD4E-CB4CCA059FC4}" type="datetimeFigureOut">
               <a:rPr lang="en-US" smtClean="0"/>
-              <a:t>1/27/13</a:t>
+              <a:t>10/27/2026</a:t>
             </a:fld>
             <a:endParaRPr lang="en-US"/>
           </a:p>
@@ -2028,7 +2044,7 @@
           <a:p>
             <a:fld id="{C1FF6DA9-008F-8B48-92A6-B652298478BF}" type="slidenum">
               <a:rPr lang="en-US" smtClean="0"/>
-              <a:t>‹#›</a:t>
+              <a:t>‹Nº›</a:t>
             </a:fld>
             <a:endParaRPr lang="en-US"/>
           </a:p>
@@ -2263,7 +2279,7 @@
           <a:p>
             <a:fld id="{5BCAD085-E8A6-8845-BD4E-CB4CCA059FC4}" type="datetimeFigureOut">
               <a:rPr lang="en-US" smtClean="0"/>
-              <a:t>1/27/13</a:t>
+              <a:t>10/27/2026</a:t>
             </a:fld>
             <a:endParaRPr lang="en-US"/>
           </a:p>
@@ -2305,7 +2321,7 @@
           <a:p>
             <a:fld id="{C1FF6DA9-008F-8B48-92A6-B652298478BF}" type="slidenum">
               <a:rPr lang="en-US" smtClean="0"/>
-              <a:t>‹#›</a:t>
+              <a:t>‹Nº›</a:t>
             </a:fld>
             <a:endParaRPr lang="en-US"/>
           </a:p>
@@ -2516,7 +2532,7 @@
           <a:p>
             <a:fld id="{5BCAD085-E8A6-8845-BD4E-CB4CCA059FC4}" type="datetimeFigureOut">
               <a:rPr lang="en-US" smtClean="0"/>
-              <a:t>1/27/13</a:t>
+              <a:t>10/27/2026</a:t>
             </a:fld>
             <a:endParaRPr lang="en-US"/>
           </a:p>
@@ -2558,7 +2574,7 @@
           <a:p>
             <a:fld id="{C1FF6DA9-008F-8B48-92A6-B652298478BF}" type="slidenum">
               <a:rPr lang="en-US" smtClean="0"/>
-              <a:t>‹#›</a:t>
+              <a:t>‹Nº›</a:t>
             </a:fld>
             <a:endParaRPr lang="en-US"/>
           </a:p>
@@ -2729,7 +2745,7 @@
           <a:p>
             <a:fld id="{5BCAD085-E8A6-8845-BD4E-CB4CCA059FC4}" type="datetimeFigureOut">
               <a:rPr lang="en-US" smtClean="0"/>
-              <a:t>1/27/13</a:t>
+              <a:t>10/27/2026</a:t>
             </a:fld>
             <a:endParaRPr lang="en-US"/>
           </a:p>
@@ -2807,7 +2823,7 @@
           <a:p>
             <a:fld id="{C1FF6DA9-008F-8B48-92A6-B652298478BF}" type="slidenum">
               <a:rPr lang="en-US" smtClean="0"/>
-              <a:t>‹#›</a:t>
+              <a:t>‹Nº›</a:t>
             </a:fld>
             <a:endParaRPr lang="en-US"/>
           </a:p>
@@ -3088,7 +3104,7 @@
 </file>
 
 <file path=ppt/slides/slide1.xml><?xml version="1.0" encoding="utf-8"?>
-<p:sld xmlns:a="http://schemas.openxmlformats.org/drawingml/2006/main" xmlns:p="http://schemas.openxmlformats.org/presentationml/2006/main" xmlns:r="http://schemas.openxmlformats.org/officeDocument/2006/relationships">
+<p:sld xmlns:a="http://schemas.openxmlformats.org/drawingml/2006/main" xmlns:r="http://schemas.openxmlformats.org/officeDocument/2006/relationships" xmlns:p="http://schemas.openxmlformats.org/presentationml/2006/main">
   <p:cSld>
     <p:spTree>
       <p:nvGrpSpPr>
@@ -3096,7 +3112,14 @@
         <p:cNvGrpSpPr/>
         <p:nvPr/>
       </p:nvGrpSpPr>
-      <p:grpSpPr/>
+      <p:grpSpPr>
+        <a:xfrm>
+          <a:off x="0" y="0"/>
+          <a:ext cx="0" cy="0"/>
+          <a:chOff x="0" y="0"/>
+          <a:chExt cx="0" cy="0"/>
+        </a:xfrm>
+      </p:grpSpPr>
       <p:sp>
         <p:nvSpPr>
           <p:cNvPr id="2" name="Rectangle 1"/>
@@ -3137,6 +3160,7 @@
           <a:lstStyle/>
           <a:p>
             <a:pPr algn="ctr"/>
+            <a:endParaRPr/>
           </a:p>
         </p:txBody>
       </p:sp>
@@ -3180,6 +3204,7 @@
           <a:lstStyle/>
           <a:p>
             <a:pPr algn="ctr"/>
+            <a:endParaRPr/>
           </a:p>
         </p:txBody>
       </p:sp>
@@ -3348,7 +3373,7 @@
           </a:fontRef>
         </p:style>
         <p:txBody>
-          <a:bodyPr rtlCol="0" anchor="ctr" wrap="square" lIns="274320" tIns="228600"/>
+          <a:bodyPr wrap="square" lIns="274320" tIns="228600" rtlCol="0" anchor="ctr"/>
           <a:lstStyle/>
           <a:p>
             <a:pPr algn="ctr">
@@ -3373,7 +3398,7 @@
               </a:spcAft>
             </a:pPr>
             <a:r>
-              <a:rPr b="1" sz="1100">
+              <a:rPr sz="1100" b="1">
                 <a:solidFill>
                   <a:srgbClr val="FFFFFF"/>
                 </a:solidFill>
@@ -3381,7 +3406,7 @@
               <a:t>Institución: </a:t>
             </a:r>
             <a:r>
-              <a:rPr b="0" sz="1100">
+              <a:rPr sz="1100" b="0">
                 <a:solidFill>
                   <a:srgbClr val="B4C3D7"/>
                 </a:solidFill>
@@ -3396,7 +3421,7 @@
               </a:spcAft>
             </a:pPr>
             <a:r>
-              <a:rPr b="1" sz="1100">
+              <a:rPr sz="1100" b="1">
                 <a:solidFill>
                   <a:srgbClr val="FFFFFF"/>
                 </a:solidFill>
@@ -3404,7 +3429,7 @@
               <a:t>Centro: </a:t>
             </a:r>
             <a:r>
-              <a:rPr b="0" sz="1100">
+              <a:rPr sz="1100" b="0">
                 <a:solidFill>
                   <a:srgbClr val="B4C3D7"/>
                 </a:solidFill>
@@ -3419,7 +3444,7 @@
               </a:spcAft>
             </a:pPr>
             <a:r>
-              <a:rPr b="1" sz="1100">
+              <a:rPr sz="1100" b="1">
                 <a:solidFill>
                   <a:srgbClr val="FFFFFF"/>
                 </a:solidFill>
@@ -3427,7 +3452,7 @@
               <a:t>Programa: </a:t>
             </a:r>
             <a:r>
-              <a:rPr b="0" sz="1100">
+              <a:rPr sz="1100" b="0">
                 <a:solidFill>
                   <a:srgbClr val="B4C3D7"/>
                 </a:solidFill>
@@ -3442,7 +3467,7 @@
               </a:spcAft>
             </a:pPr>
             <a:r>
-              <a:rPr b="1" sz="1100">
+              <a:rPr sz="1100" b="1">
                 <a:solidFill>
                   <a:srgbClr val="FFFFFF"/>
                 </a:solidFill>
@@ -3450,7 +3475,7 @@
               <a:t>Ficha: </a:t>
             </a:r>
             <a:r>
-              <a:rPr b="0" sz="1100">
+              <a:rPr sz="1100" b="0">
                 <a:solidFill>
                   <a:srgbClr val="B4C3D7"/>
                 </a:solidFill>
@@ -3465,7 +3490,7 @@
               </a:spcAft>
             </a:pPr>
             <a:r>
-              <a:rPr b="1" sz="1100">
+              <a:rPr sz="1100" b="1">
                 <a:solidFill>
                   <a:srgbClr val="FFFFFF"/>
                 </a:solidFill>
@@ -3473,7 +3498,7 @@
               <a:t>Instructor Líder: </a:t>
             </a:r>
             <a:r>
-              <a:rPr b="0" sz="1100">
+              <a:rPr sz="1100" b="0">
                 <a:solidFill>
                   <a:srgbClr val="B4C3D7"/>
                 </a:solidFill>
@@ -3488,7 +3513,7 @@
               </a:spcAft>
             </a:pPr>
             <a:r>
-              <a:rPr b="1" sz="1100">
+              <a:rPr sz="1100" b="1">
                 <a:solidFill>
                   <a:srgbClr val="FFFFFF"/>
                 </a:solidFill>
@@ -3496,7 +3521,7 @@
               <a:t>Lugar y Año: </a:t>
             </a:r>
             <a:r>
-              <a:rPr b="0" sz="1100">
+              <a:rPr sz="1100" b="0">
                 <a:solidFill>
                   <a:srgbClr val="B4C3D7"/>
                 </a:solidFill>
@@ -3544,7 +3569,7 @@
           </a:fontRef>
         </p:style>
         <p:txBody>
-          <a:bodyPr rtlCol="0" anchor="ctr" wrap="square" lIns="274320" tIns="228600"/>
+          <a:bodyPr wrap="square" lIns="274320" tIns="228600" rtlCol="0" anchor="ctr"/>
           <a:lstStyle/>
           <a:p>
             <a:pPr algn="ctr">
@@ -3569,7 +3594,7 @@
               </a:spcAft>
             </a:pPr>
             <a:r>
-              <a:rPr b="1" sz="1300">
+              <a:rPr sz="1300" b="1">
                 <a:solidFill>
                   <a:srgbClr val="FFFFFF"/>
                 </a:solidFill>
@@ -3578,7 +3603,7 @@
 </a:t>
             </a:r>
             <a:r>
-              <a:rPr b="0" sz="1050">
+              <a:rPr sz="1050" b="0">
                 <a:solidFill>
                   <a:srgbClr val="B4C3D7"/>
                 </a:solidFill>
@@ -3593,7 +3618,7 @@
               </a:spcAft>
             </a:pPr>
             <a:r>
-              <a:rPr b="1" sz="1300">
+              <a:rPr sz="1300" b="1">
                 <a:solidFill>
                   <a:srgbClr val="FFFFFF"/>
                 </a:solidFill>
@@ -3602,7 +3627,7 @@
 </a:t>
             </a:r>
             <a:r>
-              <a:rPr b="0" sz="1050">
+              <a:rPr sz="1050" b="0">
                 <a:solidFill>
                   <a:srgbClr val="B4C3D7"/>
                 </a:solidFill>
@@ -3617,7 +3642,7 @@
               </a:spcAft>
             </a:pPr>
             <a:r>
-              <a:rPr b="1" sz="1300">
+              <a:rPr sz="1300" b="1">
                 <a:solidFill>
                   <a:srgbClr val="FFFFFF"/>
                 </a:solidFill>
@@ -3626,7 +3651,7 @@
 </a:t>
             </a:r>
             <a:r>
-              <a:rPr b="0" sz="1050">
+              <a:rPr sz="1050" b="0">
                 <a:solidFill>
                   <a:srgbClr val="B4C3D7"/>
                 </a:solidFill>
@@ -3645,7 +3670,7 @@
 </file>
 
 <file path=ppt/slides/slide10.xml><?xml version="1.0" encoding="utf-8"?>
-<p:sld xmlns:a="http://schemas.openxmlformats.org/drawingml/2006/main" xmlns:p="http://schemas.openxmlformats.org/presentationml/2006/main" xmlns:r="http://schemas.openxmlformats.org/officeDocument/2006/relationships">
+<p:sld xmlns:a="http://schemas.openxmlformats.org/drawingml/2006/main" xmlns:r="http://schemas.openxmlformats.org/officeDocument/2006/relationships" xmlns:p="http://schemas.openxmlformats.org/presentationml/2006/main">
   <p:cSld>
     <p:spTree>
       <p:nvGrpSpPr>
@@ -3653,7 +3678,14 @@
         <p:cNvGrpSpPr/>
         <p:nvPr/>
       </p:nvGrpSpPr>
-      <p:grpSpPr/>
+      <p:grpSpPr>
+        <a:xfrm>
+          <a:off x="0" y="0"/>
+          <a:ext cx="0" cy="0"/>
+          <a:chOff x="0" y="0"/>
+          <a:chExt cx="0" cy="0"/>
+        </a:xfrm>
+      </p:grpSpPr>
       <p:sp>
         <p:nvSpPr>
           <p:cNvPr id="2" name="Rectangle 1"/>
@@ -3694,6 +3726,7 @@
           <a:lstStyle/>
           <a:p>
             <a:pPr algn="ctr"/>
+            <a:endParaRPr/>
           </a:p>
         </p:txBody>
       </p:sp>
@@ -3737,6 +3770,7 @@
           <a:lstStyle/>
           <a:p>
             <a:pPr algn="ctr"/>
+            <a:endParaRPr/>
           </a:p>
         </p:txBody>
       </p:sp>
@@ -3830,7 +3864,7 @@
           </a:fontRef>
         </p:style>
         <p:txBody>
-          <a:bodyPr rtlCol="0" anchor="ctr" wrap="square" lIns="228600" tIns="228600"/>
+          <a:bodyPr wrap="square" lIns="228600" tIns="228600" rtlCol="0" anchor="ctr"/>
           <a:lstStyle/>
           <a:p>
             <a:pPr algn="ctr">
@@ -3961,7 +3995,7 @@
           </a:fontRef>
         </p:style>
         <p:txBody>
-          <a:bodyPr rtlCol="0" anchor="ctr" wrap="square" lIns="228600" tIns="228600"/>
+          <a:bodyPr wrap="square" lIns="228600" tIns="228600" rtlCol="0" anchor="ctr"/>
           <a:lstStyle/>
           <a:p>
             <a:pPr algn="ctr">
@@ -4092,7 +4126,7 @@
           </a:fontRef>
         </p:style>
         <p:txBody>
-          <a:bodyPr rtlCol="0" anchor="ctr" wrap="square" lIns="228600" tIns="228600"/>
+          <a:bodyPr wrap="square" lIns="228600" tIns="228600" rtlCol="0" anchor="ctr"/>
           <a:lstStyle/>
           <a:p>
             <a:pPr algn="ctr">
@@ -4230,7 +4264,7 @@
 </file>
 
 <file path=ppt/slides/slide2.xml><?xml version="1.0" encoding="utf-8"?>
-<p:sld xmlns:a="http://schemas.openxmlformats.org/drawingml/2006/main" xmlns:p="http://schemas.openxmlformats.org/presentationml/2006/main" xmlns:r="http://schemas.openxmlformats.org/officeDocument/2006/relationships">
+<p:sld xmlns:a="http://schemas.openxmlformats.org/drawingml/2006/main" xmlns:r="http://schemas.openxmlformats.org/officeDocument/2006/relationships" xmlns:p="http://schemas.openxmlformats.org/presentationml/2006/main">
   <p:cSld>
     <p:spTree>
       <p:nvGrpSpPr>
@@ -4238,7 +4272,14 @@
         <p:cNvGrpSpPr/>
         <p:nvPr/>
       </p:nvGrpSpPr>
-      <p:grpSpPr/>
+      <p:grpSpPr>
+        <a:xfrm>
+          <a:off x="0" y="0"/>
+          <a:ext cx="0" cy="0"/>
+          <a:chOff x="0" y="0"/>
+          <a:chExt cx="0" cy="0"/>
+        </a:xfrm>
+      </p:grpSpPr>
       <p:sp>
         <p:nvSpPr>
           <p:cNvPr id="2" name="Rectangle 1"/>
@@ -4247,7 +4288,7 @@
         </p:nvSpPr>
         <p:spPr>
           <a:xfrm>
-            <a:off x="0" y="0"/>
+            <a:off x="42204" y="0"/>
             <a:ext cx="12191695" cy="6858000"/>
           </a:xfrm>
           <a:prstGeom prst="rect">
@@ -4279,6 +4320,7 @@
           <a:lstStyle/>
           <a:p>
             <a:pPr algn="ctr"/>
+            <a:endParaRPr/>
           </a:p>
         </p:txBody>
       </p:sp>
@@ -4322,6 +4364,7 @@
           <a:lstStyle/>
           <a:p>
             <a:pPr algn="ctr"/>
+            <a:endParaRPr/>
           </a:p>
         </p:txBody>
       </p:sp>
@@ -4435,7 +4478,7 @@
           </a:fontRef>
         </p:style>
         <p:txBody>
-          <a:bodyPr rtlCol="0" anchor="ctr" wrap="square"/>
+          <a:bodyPr wrap="square" rtlCol="0" anchor="ctr"/>
           <a:lstStyle/>
           <a:p>
             <a:pPr algn="ctr">
@@ -4505,6 +4548,7 @@
           <a:lstStyle/>
           <a:p>
             <a:pPr algn="ctr"/>
+            <a:endParaRPr/>
           </a:p>
         </p:txBody>
       </p:sp>
@@ -4622,6 +4666,7 @@
           <a:lstStyle/>
           <a:p>
             <a:pPr algn="ctr"/>
+            <a:endParaRPr/>
           </a:p>
         </p:txBody>
       </p:sp>
@@ -4764,8 +4809,18 @@
               </a:defRPr>
             </a:pPr>
             <a:r>
-              <a:t>Yurleidis Londoño</a:t>
-            </a:r>
+              <a:rPr dirty="0" err="1"/>
+              <a:t>Yurleidis</a:t>
+            </a:r>
+            <a:r>
+              <a:rPr dirty="0"/>
+              <a:t> </a:t>
+            </a:r>
+            <a:r>
+              <a:rPr dirty="0" err="1"/>
+              <a:t>Londoño</a:t>
+            </a:r>
+            <a:endParaRPr dirty="0"/>
           </a:p>
         </p:txBody>
       </p:sp>
@@ -4866,6 +4921,7 @@
           <a:lstStyle/>
           <a:p>
             <a:pPr algn="ctr"/>
+            <a:endParaRPr/>
           </a:p>
         </p:txBody>
       </p:sp>
@@ -5110,6 +5166,7 @@
           <a:lstStyle/>
           <a:p>
             <a:pPr algn="ctr"/>
+            <a:endParaRPr/>
           </a:p>
         </p:txBody>
       </p:sp>
@@ -5354,6 +5411,7 @@
           <a:lstStyle/>
           <a:p>
             <a:pPr algn="ctr"/>
+            <a:endParaRPr/>
           </a:p>
         </p:txBody>
       </p:sp>
@@ -5598,6 +5656,7 @@
           <a:lstStyle/>
           <a:p>
             <a:pPr algn="ctr"/>
+            <a:endParaRPr/>
           </a:p>
         </p:txBody>
       </p:sp>
@@ -5842,6 +5901,7 @@
           <a:lstStyle/>
           <a:p>
             <a:pPr algn="ctr"/>
+            <a:endParaRPr/>
           </a:p>
         </p:txBody>
       </p:sp>
@@ -6053,7 +6113,7 @@
 </file>
 
 <file path=ppt/slides/slide3.xml><?xml version="1.0" encoding="utf-8"?>
-<p:sld xmlns:a="http://schemas.openxmlformats.org/drawingml/2006/main" xmlns:p="http://schemas.openxmlformats.org/presentationml/2006/main" xmlns:r="http://schemas.openxmlformats.org/officeDocument/2006/relationships">
+<p:sld xmlns:a="http://schemas.openxmlformats.org/drawingml/2006/main" xmlns:r="http://schemas.openxmlformats.org/officeDocument/2006/relationships" xmlns:p="http://schemas.openxmlformats.org/presentationml/2006/main">
   <p:cSld>
     <p:spTree>
       <p:nvGrpSpPr>
@@ -6061,7 +6121,14 @@
         <p:cNvGrpSpPr/>
         <p:nvPr/>
       </p:nvGrpSpPr>
-      <p:grpSpPr/>
+      <p:grpSpPr>
+        <a:xfrm>
+          <a:off x="0" y="0"/>
+          <a:ext cx="0" cy="0"/>
+          <a:chOff x="0" y="0"/>
+          <a:chExt cx="0" cy="0"/>
+        </a:xfrm>
+      </p:grpSpPr>
       <p:sp>
         <p:nvSpPr>
           <p:cNvPr id="2" name="Rectangle 1"/>
@@ -6102,6 +6169,7 @@
           <a:lstStyle/>
           <a:p>
             <a:pPr algn="ctr"/>
+            <a:endParaRPr/>
           </a:p>
         </p:txBody>
       </p:sp>
@@ -6145,6 +6213,7 @@
           <a:lstStyle/>
           <a:p>
             <a:pPr algn="ctr"/>
+            <a:endParaRPr/>
           </a:p>
         </p:txBody>
       </p:sp>
@@ -6258,7 +6327,7 @@
           </a:fontRef>
         </p:style>
         <p:txBody>
-          <a:bodyPr rtlCol="0" anchor="ctr" wrap="square"/>
+          <a:bodyPr wrap="square" rtlCol="0" anchor="ctr"/>
           <a:lstStyle/>
           <a:p>
             <a:pPr algn="ctr">
@@ -6328,6 +6397,7 @@
           <a:lstStyle/>
           <a:p>
             <a:pPr algn="ctr"/>
+            <a:endParaRPr/>
           </a:p>
         </p:txBody>
       </p:sp>
@@ -6441,7 +6511,7 @@
           </a:fontRef>
         </p:style>
         <p:txBody>
-          <a:bodyPr rtlCol="0" anchor="ctr" wrap="square" lIns="228600" rIns="228600" tIns="201168" bIns="182880"/>
+          <a:bodyPr wrap="square" lIns="228600" tIns="201168" rIns="228600" bIns="182880" rtlCol="0" anchor="ctr"/>
           <a:lstStyle/>
           <a:p>
             <a:pPr algn="ctr">
@@ -6603,7 +6673,7 @@
           </a:fontRef>
         </p:style>
         <p:txBody>
-          <a:bodyPr rtlCol="0" anchor="ctr" wrap="square" lIns="228600" rIns="228600" tIns="201168" bIns="182880"/>
+          <a:bodyPr wrap="square" lIns="228600" tIns="201168" rIns="228600" bIns="182880" rtlCol="0" anchor="ctr"/>
           <a:lstStyle/>
           <a:p>
             <a:pPr algn="ctr">
@@ -6736,7 +6806,7 @@
 </file>
 
 <file path=ppt/slides/slide4.xml><?xml version="1.0" encoding="utf-8"?>
-<p:sld xmlns:a="http://schemas.openxmlformats.org/drawingml/2006/main" xmlns:p="http://schemas.openxmlformats.org/presentationml/2006/main" xmlns:r="http://schemas.openxmlformats.org/officeDocument/2006/relationships">
+<p:sld xmlns:a="http://schemas.openxmlformats.org/drawingml/2006/main" xmlns:r="http://schemas.openxmlformats.org/officeDocument/2006/relationships" xmlns:p="http://schemas.openxmlformats.org/presentationml/2006/main">
   <p:cSld>
     <p:spTree>
       <p:nvGrpSpPr>
@@ -6744,7 +6814,14 @@
         <p:cNvGrpSpPr/>
         <p:nvPr/>
       </p:nvGrpSpPr>
-      <p:grpSpPr/>
+      <p:grpSpPr>
+        <a:xfrm>
+          <a:off x="0" y="0"/>
+          <a:ext cx="0" cy="0"/>
+          <a:chOff x="0" y="0"/>
+          <a:chExt cx="0" cy="0"/>
+        </a:xfrm>
+      </p:grpSpPr>
       <p:sp>
         <p:nvSpPr>
           <p:cNvPr id="2" name="Rectangle 1"/>
@@ -6785,6 +6862,7 @@
           <a:lstStyle/>
           <a:p>
             <a:pPr algn="ctr"/>
+            <a:endParaRPr/>
           </a:p>
         </p:txBody>
       </p:sp>
@@ -6828,6 +6906,7 @@
           <a:lstStyle/>
           <a:p>
             <a:pPr algn="ctr"/>
+            <a:endParaRPr/>
           </a:p>
         </p:txBody>
       </p:sp>
@@ -6941,7 +7020,7 @@
           </a:fontRef>
         </p:style>
         <p:txBody>
-          <a:bodyPr rtlCol="0" anchor="ctr" wrap="square"/>
+          <a:bodyPr wrap="square" rtlCol="0" anchor="ctr"/>
           <a:lstStyle/>
           <a:p>
             <a:pPr algn="ctr">
@@ -7011,6 +7090,7 @@
           <a:lstStyle/>
           <a:p>
             <a:pPr algn="ctr"/>
+            <a:endParaRPr/>
           </a:p>
         </p:txBody>
       </p:sp>
@@ -7124,7 +7204,7 @@
           </a:fontRef>
         </p:style>
         <p:txBody>
-          <a:bodyPr rtlCol="0" anchor="ctr" wrap="square" lIns="228600" rIns="228600" tIns="201168" bIns="182880"/>
+          <a:bodyPr wrap="square" lIns="228600" tIns="201168" rIns="228600" bIns="182880" rtlCol="0" anchor="ctr"/>
           <a:lstStyle/>
           <a:p>
             <a:pPr algn="ctr">
@@ -7286,7 +7366,7 @@
           </a:fontRef>
         </p:style>
         <p:txBody>
-          <a:bodyPr rtlCol="0" anchor="ctr" wrap="square" lIns="228600" rIns="228600" tIns="201168" bIns="182880"/>
+          <a:bodyPr wrap="square" lIns="228600" tIns="201168" rIns="228600" bIns="182880" rtlCol="0" anchor="ctr"/>
           <a:lstStyle/>
           <a:p>
             <a:pPr algn="ctr">
@@ -7448,7 +7528,7 @@
           </a:fontRef>
         </p:style>
         <p:txBody>
-          <a:bodyPr rtlCol="0" anchor="ctr" wrap="square" lIns="228600" rIns="228600" tIns="201168" bIns="182880"/>
+          <a:bodyPr wrap="square" lIns="228600" tIns="201168" rIns="228600" bIns="182880" rtlCol="0" anchor="ctr"/>
           <a:lstStyle/>
           <a:p>
             <a:pPr algn="ctr">
@@ -7581,7 +7661,7 @@
 </file>
 
 <file path=ppt/slides/slide5.xml><?xml version="1.0" encoding="utf-8"?>
-<p:sld xmlns:a="http://schemas.openxmlformats.org/drawingml/2006/main" xmlns:p="http://schemas.openxmlformats.org/presentationml/2006/main" xmlns:r="http://schemas.openxmlformats.org/officeDocument/2006/relationships">
+<p:sld xmlns:a="http://schemas.openxmlformats.org/drawingml/2006/main" xmlns:r="http://schemas.openxmlformats.org/officeDocument/2006/relationships" xmlns:p="http://schemas.openxmlformats.org/presentationml/2006/main">
   <p:cSld>
     <p:spTree>
       <p:nvGrpSpPr>
@@ -7589,7 +7669,14 @@
         <p:cNvGrpSpPr/>
         <p:nvPr/>
       </p:nvGrpSpPr>
-      <p:grpSpPr/>
+      <p:grpSpPr>
+        <a:xfrm>
+          <a:off x="0" y="0"/>
+          <a:ext cx="0" cy="0"/>
+          <a:chOff x="0" y="0"/>
+          <a:chExt cx="0" cy="0"/>
+        </a:xfrm>
+      </p:grpSpPr>
       <p:sp>
         <p:nvSpPr>
           <p:cNvPr id="2" name="Rectangle 1"/>
@@ -7630,6 +7717,7 @@
           <a:lstStyle/>
           <a:p>
             <a:pPr algn="ctr"/>
+            <a:endParaRPr/>
           </a:p>
         </p:txBody>
       </p:sp>
@@ -7673,6 +7761,7 @@
           <a:lstStyle/>
           <a:p>
             <a:pPr algn="ctr"/>
+            <a:endParaRPr/>
           </a:p>
         </p:txBody>
       </p:sp>
@@ -7786,7 +7875,7 @@
           </a:fontRef>
         </p:style>
         <p:txBody>
-          <a:bodyPr rtlCol="0" anchor="ctr" wrap="square"/>
+          <a:bodyPr wrap="square" rtlCol="0" anchor="ctr"/>
           <a:lstStyle/>
           <a:p>
             <a:pPr algn="ctr">
@@ -7856,6 +7945,7 @@
           <a:lstStyle/>
           <a:p>
             <a:pPr algn="ctr"/>
+            <a:endParaRPr/>
           </a:p>
         </p:txBody>
       </p:sp>
@@ -7969,7 +8059,7 @@
           </a:fontRef>
         </p:style>
         <p:txBody>
-          <a:bodyPr rtlCol="0" anchor="ctr" wrap="square" lIns="228600" rIns="228600" tIns="201168" bIns="182880"/>
+          <a:bodyPr wrap="square" lIns="228600" tIns="201168" rIns="228600" bIns="182880" rtlCol="0" anchor="ctr"/>
           <a:lstStyle/>
           <a:p>
             <a:pPr algn="ctr">
@@ -8131,7 +8221,7 @@
           </a:fontRef>
         </p:style>
         <p:txBody>
-          <a:bodyPr rtlCol="0" anchor="ctr" wrap="square" lIns="228600" rIns="228600" tIns="201168" bIns="182880"/>
+          <a:bodyPr wrap="square" lIns="228600" tIns="201168" rIns="228600" bIns="182880" rtlCol="0" anchor="ctr"/>
           <a:lstStyle/>
           <a:p>
             <a:pPr algn="ctr">
@@ -8264,7 +8354,7 @@
 </file>
 
 <file path=ppt/slides/slide6.xml><?xml version="1.0" encoding="utf-8"?>
-<p:sld xmlns:a="http://schemas.openxmlformats.org/drawingml/2006/main" xmlns:p="http://schemas.openxmlformats.org/presentationml/2006/main" xmlns:r="http://schemas.openxmlformats.org/officeDocument/2006/relationships">
+<p:sld xmlns:a="http://schemas.openxmlformats.org/drawingml/2006/main" xmlns:r="http://schemas.openxmlformats.org/officeDocument/2006/relationships" xmlns:p="http://schemas.openxmlformats.org/presentationml/2006/main">
   <p:cSld>
     <p:spTree>
       <p:nvGrpSpPr>
@@ -8272,7 +8362,14 @@
         <p:cNvGrpSpPr/>
         <p:nvPr/>
       </p:nvGrpSpPr>
-      <p:grpSpPr/>
+      <p:grpSpPr>
+        <a:xfrm>
+          <a:off x="0" y="0"/>
+          <a:ext cx="0" cy="0"/>
+          <a:chOff x="0" y="0"/>
+          <a:chExt cx="0" cy="0"/>
+        </a:xfrm>
+      </p:grpSpPr>
       <p:sp>
         <p:nvSpPr>
           <p:cNvPr id="2" name="Rectangle 1"/>
@@ -8313,6 +8410,7 @@
           <a:lstStyle/>
           <a:p>
             <a:pPr algn="ctr"/>
+            <a:endParaRPr/>
           </a:p>
         </p:txBody>
       </p:sp>
@@ -8356,6 +8454,7 @@
           <a:lstStyle/>
           <a:p>
             <a:pPr algn="ctr"/>
+            <a:endParaRPr/>
           </a:p>
         </p:txBody>
       </p:sp>
@@ -8469,7 +8568,7 @@
           </a:fontRef>
         </p:style>
         <p:txBody>
-          <a:bodyPr rtlCol="0" anchor="ctr" wrap="square"/>
+          <a:bodyPr wrap="square" rtlCol="0" anchor="ctr"/>
           <a:lstStyle/>
           <a:p>
             <a:pPr algn="ctr">
@@ -8539,6 +8638,7 @@
           <a:lstStyle/>
           <a:p>
             <a:pPr algn="ctr"/>
+            <a:endParaRPr/>
           </a:p>
         </p:txBody>
       </p:sp>
@@ -8652,7 +8752,7 @@
           </a:fontRef>
         </p:style>
         <p:txBody>
-          <a:bodyPr rtlCol="0" anchor="ctr" wrap="square" lIns="228600" rIns="228600" tIns="201168" bIns="182880"/>
+          <a:bodyPr wrap="square" lIns="228600" tIns="201168" rIns="228600" bIns="182880" rtlCol="0" anchor="ctr"/>
           <a:lstStyle/>
           <a:p>
             <a:pPr algn="ctr">
@@ -8814,7 +8914,7 @@
           </a:fontRef>
         </p:style>
         <p:txBody>
-          <a:bodyPr rtlCol="0" anchor="ctr" wrap="square" lIns="228600" rIns="228600" tIns="201168" bIns="182880"/>
+          <a:bodyPr wrap="square" lIns="228600" tIns="201168" rIns="228600" bIns="182880" rtlCol="0" anchor="ctr"/>
           <a:lstStyle/>
           <a:p>
             <a:pPr algn="ctr">
@@ -8947,7 +9047,7 @@
 </file>
 
 <file path=ppt/slides/slide7.xml><?xml version="1.0" encoding="utf-8"?>
-<p:sld xmlns:a="http://schemas.openxmlformats.org/drawingml/2006/main" xmlns:p="http://schemas.openxmlformats.org/presentationml/2006/main" xmlns:r="http://schemas.openxmlformats.org/officeDocument/2006/relationships">
+<p:sld xmlns:a="http://schemas.openxmlformats.org/drawingml/2006/main" xmlns:r="http://schemas.openxmlformats.org/officeDocument/2006/relationships" xmlns:p="http://schemas.openxmlformats.org/presentationml/2006/main">
   <p:cSld>
     <p:spTree>
       <p:nvGrpSpPr>
@@ -8955,7 +9055,14 @@
         <p:cNvGrpSpPr/>
         <p:nvPr/>
       </p:nvGrpSpPr>
-      <p:grpSpPr/>
+      <p:grpSpPr>
+        <a:xfrm>
+          <a:off x="0" y="0"/>
+          <a:ext cx="0" cy="0"/>
+          <a:chOff x="0" y="0"/>
+          <a:chExt cx="0" cy="0"/>
+        </a:xfrm>
+      </p:grpSpPr>
       <p:sp>
         <p:nvSpPr>
           <p:cNvPr id="2" name="Rectangle 1"/>
@@ -8996,6 +9103,7 @@
           <a:lstStyle/>
           <a:p>
             <a:pPr algn="ctr"/>
+            <a:endParaRPr/>
           </a:p>
         </p:txBody>
       </p:sp>
@@ -9039,6 +9147,7 @@
           <a:lstStyle/>
           <a:p>
             <a:pPr algn="ctr"/>
+            <a:endParaRPr/>
           </a:p>
         </p:txBody>
       </p:sp>
@@ -9152,7 +9261,7 @@
           </a:fontRef>
         </p:style>
         <p:txBody>
-          <a:bodyPr rtlCol="0" anchor="ctr" wrap="square"/>
+          <a:bodyPr wrap="square" rtlCol="0" anchor="ctr"/>
           <a:lstStyle/>
           <a:p>
             <a:pPr algn="ctr">
@@ -9222,6 +9331,7 @@
           <a:lstStyle/>
           <a:p>
             <a:pPr algn="ctr"/>
+            <a:endParaRPr/>
           </a:p>
         </p:txBody>
       </p:sp>
@@ -9335,7 +9445,7 @@
           </a:fontRef>
         </p:style>
         <p:txBody>
-          <a:bodyPr rtlCol="0" anchor="ctr" wrap="square" lIns="228600" rIns="228600" tIns="201168" bIns="182880"/>
+          <a:bodyPr wrap="square" lIns="228600" tIns="201168" rIns="228600" bIns="182880" rtlCol="0" anchor="ctr"/>
           <a:lstStyle/>
           <a:p>
             <a:pPr algn="ctr">
@@ -9497,7 +9607,7 @@
           </a:fontRef>
         </p:style>
         <p:txBody>
-          <a:bodyPr rtlCol="0" anchor="ctr" wrap="square" lIns="228600" rIns="228600" tIns="201168" bIns="182880"/>
+          <a:bodyPr wrap="square" lIns="228600" tIns="201168" rIns="228600" bIns="182880" rtlCol="0" anchor="ctr"/>
           <a:lstStyle/>
           <a:p>
             <a:pPr algn="ctr">
@@ -9630,7 +9740,7 @@
 </file>
 
 <file path=ppt/slides/slide8.xml><?xml version="1.0" encoding="utf-8"?>
-<p:sld xmlns:a="http://schemas.openxmlformats.org/drawingml/2006/main" xmlns:p="http://schemas.openxmlformats.org/presentationml/2006/main" xmlns:r="http://schemas.openxmlformats.org/officeDocument/2006/relationships">
+<p:sld xmlns:a="http://schemas.openxmlformats.org/drawingml/2006/main" xmlns:r="http://schemas.openxmlformats.org/officeDocument/2006/relationships" xmlns:p="http://schemas.openxmlformats.org/presentationml/2006/main">
   <p:cSld>
     <p:spTree>
       <p:nvGrpSpPr>
@@ -9638,7 +9748,14 @@
         <p:cNvGrpSpPr/>
         <p:nvPr/>
       </p:nvGrpSpPr>
-      <p:grpSpPr/>
+      <p:grpSpPr>
+        <a:xfrm>
+          <a:off x="0" y="0"/>
+          <a:ext cx="0" cy="0"/>
+          <a:chOff x="0" y="0"/>
+          <a:chExt cx="0" cy="0"/>
+        </a:xfrm>
+      </p:grpSpPr>
       <p:sp>
         <p:nvSpPr>
           <p:cNvPr id="2" name="Rectangle 1"/>
@@ -9679,6 +9796,7 @@
           <a:lstStyle/>
           <a:p>
             <a:pPr algn="ctr"/>
+            <a:endParaRPr/>
           </a:p>
         </p:txBody>
       </p:sp>
@@ -9722,6 +9840,7 @@
           <a:lstStyle/>
           <a:p>
             <a:pPr algn="ctr"/>
+            <a:endParaRPr/>
           </a:p>
         </p:txBody>
       </p:sp>
@@ -9835,7 +9954,7 @@
           </a:fontRef>
         </p:style>
         <p:txBody>
-          <a:bodyPr rtlCol="0" anchor="ctr" wrap="square"/>
+          <a:bodyPr wrap="square" rtlCol="0" anchor="ctr"/>
           <a:lstStyle/>
           <a:p>
             <a:pPr algn="ctr">
@@ -9905,6 +10024,7 @@
           <a:lstStyle/>
           <a:p>
             <a:pPr algn="ctr"/>
+            <a:endParaRPr/>
           </a:p>
         </p:txBody>
       </p:sp>
@@ -10018,7 +10138,7 @@
           </a:fontRef>
         </p:style>
         <p:txBody>
-          <a:bodyPr rtlCol="0" anchor="ctr" wrap="square" lIns="228600" rIns="228600" tIns="201168" bIns="182880"/>
+          <a:bodyPr wrap="square" lIns="228600" tIns="201168" rIns="228600" bIns="182880" rtlCol="0" anchor="ctr"/>
           <a:lstStyle/>
           <a:p>
             <a:pPr algn="ctr">
@@ -10180,7 +10300,7 @@
           </a:fontRef>
         </p:style>
         <p:txBody>
-          <a:bodyPr rtlCol="0" anchor="ctr" wrap="square" lIns="228600" rIns="228600" tIns="201168" bIns="182880"/>
+          <a:bodyPr wrap="square" lIns="228600" tIns="201168" rIns="228600" bIns="182880" rtlCol="0" anchor="ctr"/>
           <a:lstStyle/>
           <a:p>
             <a:pPr algn="ctr">
@@ -10313,7 +10433,7 @@
 </file>
 
 <file path=ppt/slides/slide9.xml><?xml version="1.0" encoding="utf-8"?>
-<p:sld xmlns:a="http://schemas.openxmlformats.org/drawingml/2006/main" xmlns:p="http://schemas.openxmlformats.org/presentationml/2006/main" xmlns:r="http://schemas.openxmlformats.org/officeDocument/2006/relationships">
+<p:sld xmlns:a="http://schemas.openxmlformats.org/drawingml/2006/main" xmlns:r="http://schemas.openxmlformats.org/officeDocument/2006/relationships" xmlns:p="http://schemas.openxmlformats.org/presentationml/2006/main">
   <p:cSld>
     <p:spTree>
       <p:nvGrpSpPr>
@@ -10321,7 +10441,14 @@
         <p:cNvGrpSpPr/>
         <p:nvPr/>
       </p:nvGrpSpPr>
-      <p:grpSpPr/>
+      <p:grpSpPr>
+        <a:xfrm>
+          <a:off x="0" y="0"/>
+          <a:ext cx="0" cy="0"/>
+          <a:chOff x="0" y="0"/>
+          <a:chExt cx="0" cy="0"/>
+        </a:xfrm>
+      </p:grpSpPr>
       <p:sp>
         <p:nvSpPr>
           <p:cNvPr id="2" name="Rectangle 1"/>
@@ -10362,6 +10489,7 @@
           <a:lstStyle/>
           <a:p>
             <a:pPr algn="ctr"/>
+            <a:endParaRPr/>
           </a:p>
         </p:txBody>
       </p:sp>
@@ -10405,6 +10533,7 @@
           <a:lstStyle/>
           <a:p>
             <a:pPr algn="ctr"/>
+            <a:endParaRPr/>
           </a:p>
         </p:txBody>
       </p:sp>
@@ -10518,7 +10647,7 @@
           </a:fontRef>
         </p:style>
         <p:txBody>
-          <a:bodyPr rtlCol="0" anchor="ctr" wrap="square"/>
+          <a:bodyPr wrap="square" rtlCol="0" anchor="ctr"/>
           <a:lstStyle/>
           <a:p>
             <a:pPr algn="ctr">
@@ -10588,6 +10717,7 @@
           <a:lstStyle/>
           <a:p>
             <a:pPr algn="ctr"/>
+            <a:endParaRPr/>
           </a:p>
         </p:txBody>
       </p:sp>
@@ -10701,7 +10831,7 @@
           </a:fontRef>
         </p:style>
         <p:txBody>
-          <a:bodyPr rtlCol="0" anchor="ctr" wrap="square" lIns="228600" rIns="228600" tIns="201168" bIns="182880"/>
+          <a:bodyPr wrap="square" lIns="228600" tIns="201168" rIns="228600" bIns="182880" rtlCol="0" anchor="ctr"/>
           <a:lstStyle/>
           <a:p>
             <a:pPr algn="ctr">
@@ -10863,7 +10993,7 @@
           </a:fontRef>
         </p:style>
         <p:txBody>
-          <a:bodyPr rtlCol="0" anchor="ctr" wrap="square" lIns="228600" rIns="228600" tIns="201168" bIns="182880"/>
+          <a:bodyPr wrap="square" lIns="228600" tIns="201168" rIns="228600" bIns="182880" rtlCol="0" anchor="ctr"/>
           <a:lstStyle/>
           <a:p>
             <a:pPr algn="ctr">

</xml_diff>